<commit_message>
Update: add field-specific extraction for speed optimization slide
- Prompt change can extract only needed fields (fewer tokens = faster)
- JSON structured output for automated parsing
- Batch pipeline and future model update tracking

Co-Authored-By: Claude Opus 4.6 <noreply@anthropic.com>
</commit_message>
<xml_diff>
--- a/qwendata/Qwen_0.8B_OCR_Report.pptx
+++ b/qwendata/Qwen_0.8B_OCR_Report.pptx
@@ -14,6 +14,7 @@
     <p:sldId id="262" r:id="rId13"/>
     <p:sldId id="263" r:id="rId14"/>
     <p:sldId id="264" r:id="rId15"/>
+    <p:sldId id="265" r:id="rId16"/>
   </p:sldIdLst>
   <p:sldSz cx="12191695" cy="6858000" type="screen4x3"/>
   <p:notesSz cx="6858000" cy="9144000"/>
@@ -3307,6 +3308,521 @@
             </a:pPr>
             <a:r>
               <a:t>Windows 11 Pro  |  CUDA 13.0  |  llama.cpp build 8194</a:t>
+            </a:r>
+          </a:p>
+        </p:txBody>
+      </p:sp>
+    </p:spTree>
+  </p:cSld>
+  <p:clrMapOvr>
+    <a:masterClrMapping/>
+  </p:clrMapOvr>
+</p:sld>
+</file>
+
+<file path=ppt/slides/slide10.xml><?xml version="1.0" encoding="utf-8"?>
+<p:sld xmlns:a="http://schemas.openxmlformats.org/drawingml/2006/main" xmlns:p="http://schemas.openxmlformats.org/presentationml/2006/main" xmlns:r="http://schemas.openxmlformats.org/officeDocument/2006/relationships">
+  <p:cSld>
+    <p:bg>
+      <p:bgPr>
+        <a:solidFill>
+          <a:srgbClr val="1A1A2E"/>
+        </a:solidFill>
+        <a:effectLst/>
+      </p:bgPr>
+    </p:bg>
+    <p:spTree>
+      <p:nvGrpSpPr>
+        <p:cNvPr id="1" name=""/>
+        <p:cNvGrpSpPr/>
+        <p:nvPr/>
+      </p:nvGrpSpPr>
+      <p:grpSpPr/>
+      <p:sp>
+        <p:nvSpPr>
+          <p:cNvPr id="2" name="TextBox 1"/>
+          <p:cNvSpPr txBox="1"/>
+          <p:nvPr/>
+        </p:nvSpPr>
+        <p:spPr>
+          <a:xfrm>
+            <a:off x="457200" y="274320"/>
+            <a:ext cx="10972800" cy="640080"/>
+          </a:xfrm>
+          <a:prstGeom prst="rect">
+            <a:avLst/>
+          </a:prstGeom>
+          <a:noFill/>
+        </p:spPr>
+        <p:txBody>
+          <a:bodyPr wrap="square">
+            <a:spAutoFit/>
+          </a:bodyPr>
+          <a:lstStyle/>
+          <a:p>
+            <a:pPr algn="l">
+              <a:defRPr sz="3200" b="1">
+                <a:solidFill>
+                  <a:srgbClr val="0074D9"/>
+                </a:solidFill>
+              </a:defRPr>
+            </a:pPr>
+            <a:r>
+              <a:t>향후 추가 최적화 방안</a:t>
+            </a:r>
+          </a:p>
+        </p:txBody>
+      </p:sp>
+      <p:sp>
+        <p:nvSpPr>
+          <p:cNvPr id="3" name="TextBox 2"/>
+          <p:cNvSpPr txBox="1"/>
+          <p:nvPr/>
+        </p:nvSpPr>
+        <p:spPr>
+          <a:xfrm>
+            <a:off x="457200" y="1097280"/>
+            <a:ext cx="5486400" cy="5029200"/>
+          </a:xfrm>
+          <a:prstGeom prst="rect">
+            <a:avLst/>
+          </a:prstGeom>
+          <a:noFill/>
+        </p:spPr>
+        <p:txBody>
+          <a:bodyPr wrap="square">
+            <a:spAutoFit/>
+          </a:bodyPr>
+          <a:lstStyle/>
+          <a:p>
+            <a:pPr algn="l">
+              <a:defRPr sz="1800" b="1">
+                <a:solidFill>
+                  <a:srgbClr val="2ECC71"/>
+                </a:solidFill>
+              </a:defRPr>
+            </a:pPr>
+            <a:r>
+              <a:t>특정 필드만 추출하여 속도 추가 단축</a:t>
+            </a:r>
+          </a:p>
+          <a:p>
+            <a:pPr algn="l">
+              <a:defRPr sz="800" b="0">
+                <a:solidFill>
+                  <a:srgbClr val="FFFFFF"/>
+                </a:solidFill>
+              </a:defRPr>
+            </a:pPr>
+          </a:p>
+          <a:p>
+            <a:pPr algn="l">
+              <a:defRPr sz="1500" b="1">
+                <a:solidFill>
+                  <a:srgbClr val="FFFFFF"/>
+                </a:solidFill>
+              </a:defRPr>
+            </a:pPr>
+            <a:r>
+              <a:t>현재: 라벨 전체 텍스트 출력</a:t>
+            </a:r>
+          </a:p>
+          <a:p>
+            <a:pPr algn="l">
+              <a:defRPr sz="1200" b="0">
+                <a:solidFill>
+                  <a:srgbClr val="BDBDBD"/>
+                </a:solidFill>
+              </a:defRPr>
+            </a:pPr>
+            <a:r>
+              <a:t>  프롬프트: 'Read all text in this image'</a:t>
+            </a:r>
+          </a:p>
+          <a:p>
+            <a:pPr algn="l">
+              <a:defRPr sz="1200" b="0">
+                <a:solidFill>
+                  <a:srgbClr val="BDBDBD"/>
+                </a:solidFill>
+              </a:defRPr>
+            </a:pPr>
+            <a:r>
+              <a:t>  -&gt; 전체 필드 출력 (180~256 tokens)</a:t>
+            </a:r>
+          </a:p>
+          <a:p>
+            <a:pPr algn="l">
+              <a:defRPr sz="1200" b="0">
+                <a:solidFill>
+                  <a:srgbClr val="BDBDBD"/>
+                </a:solidFill>
+              </a:defRPr>
+            </a:pPr>
+            <a:r>
+              <a:t>  -&gt; 소요 시간: 1.56초</a:t>
+            </a:r>
+          </a:p>
+          <a:p>
+            <a:pPr algn="l">
+              <a:defRPr sz="1000" b="0">
+                <a:solidFill>
+                  <a:srgbClr val="FFFFFF"/>
+                </a:solidFill>
+              </a:defRPr>
+            </a:pPr>
+          </a:p>
+          <a:p>
+            <a:pPr algn="l">
+              <a:defRPr sz="1500" b="1">
+                <a:solidFill>
+                  <a:srgbClr val="2ECC71"/>
+                </a:solidFill>
+              </a:defRPr>
+            </a:pPr>
+            <a:r>
+              <a:t>개선: 필요한 필드만 추출</a:t>
+            </a:r>
+          </a:p>
+          <a:p>
+            <a:pPr algn="l">
+              <a:defRPr sz="1200" b="0">
+                <a:solidFill>
+                  <a:srgbClr val="BDBDBD"/>
+                </a:solidFill>
+              </a:defRPr>
+            </a:pPr>
+            <a:r>
+              <a:t>  프롬프트 예시:</a:t>
+            </a:r>
+          </a:p>
+          <a:p>
+            <a:pPr algn="l">
+              <a:defRPr sz="1300" b="0">
+                <a:solidFill>
+                  <a:srgbClr val="FFFFFF"/>
+                </a:solidFill>
+              </a:defRPr>
+            </a:pPr>
+            <a:r>
+              <a:t>  'Extract only ITEM field. /no_think'</a:t>
+            </a:r>
+          </a:p>
+          <a:p>
+            <a:pPr algn="l">
+              <a:defRPr sz="1300" b="0">
+                <a:solidFill>
+                  <a:srgbClr val="FFFFFF"/>
+                </a:solidFill>
+              </a:defRPr>
+            </a:pPr>
+            <a:r>
+              <a:t>  'Read DEVICE and LOT NO. /no_think'</a:t>
+            </a:r>
+          </a:p>
+          <a:p>
+            <a:pPr algn="l">
+              <a:defRPr sz="800" b="0">
+                <a:solidFill>
+                  <a:srgbClr val="FFFFFF"/>
+                </a:solidFill>
+              </a:defRPr>
+            </a:pPr>
+          </a:p>
+          <a:p>
+            <a:pPr algn="l">
+              <a:defRPr sz="1300" b="0">
+                <a:solidFill>
+                  <a:srgbClr val="FFFFFF"/>
+                </a:solidFill>
+              </a:defRPr>
+            </a:pPr>
+            <a:r>
+              <a:t>  -&gt; 출력 토큰 수 대폭 감소</a:t>
+            </a:r>
+          </a:p>
+          <a:p>
+            <a:pPr algn="l">
+              <a:defRPr sz="1300" b="0">
+                <a:solidFill>
+                  <a:srgbClr val="FFFFFF"/>
+                </a:solidFill>
+              </a:defRPr>
+            </a:pPr>
+            <a:r>
+              <a:t>  -&gt; 생성 시간 단축 (토큰 수에 비례)</a:t>
+            </a:r>
+          </a:p>
+          <a:p>
+            <a:pPr algn="l">
+              <a:defRPr sz="1000" b="0">
+                <a:solidFill>
+                  <a:srgbClr val="FFFFFF"/>
+                </a:solidFill>
+              </a:defRPr>
+            </a:pPr>
+          </a:p>
+          <a:p>
+            <a:pPr algn="l">
+              <a:defRPr sz="1500" b="1">
+                <a:solidFill>
+                  <a:srgbClr val="F39C12"/>
+                </a:solidFill>
+              </a:defRPr>
+            </a:pPr>
+            <a:r>
+              <a:t>LLM 기반 OCR의 장점:</a:t>
+            </a:r>
+          </a:p>
+          <a:p>
+            <a:pPr algn="l">
+              <a:defRPr sz="1300" b="0">
+                <a:solidFill>
+                  <a:srgbClr val="FFFFFF"/>
+                </a:solidFill>
+              </a:defRPr>
+            </a:pPr>
+            <a:r>
+              <a:t>  프롬프트만 변경하면 추출 대상 자유 조정</a:t>
+            </a:r>
+          </a:p>
+          <a:p>
+            <a:pPr algn="l">
+              <a:defRPr sz="1300" b="0">
+                <a:solidFill>
+                  <a:srgbClr val="FFFFFF"/>
+                </a:solidFill>
+              </a:defRPr>
+            </a:pPr>
+            <a:r>
+              <a:t>  코드 수정 없이 유연한 필드 선택 가능</a:t>
+            </a:r>
+          </a:p>
+        </p:txBody>
+      </p:sp>
+      <p:sp>
+        <p:nvSpPr>
+          <p:cNvPr id="4" name="TextBox 3"/>
+          <p:cNvSpPr txBox="1"/>
+          <p:nvPr/>
+        </p:nvSpPr>
+        <p:spPr>
+          <a:xfrm>
+            <a:off x="6400800" y="1097280"/>
+            <a:ext cx="5029200" cy="5029200"/>
+          </a:xfrm>
+          <a:prstGeom prst="rect">
+            <a:avLst/>
+          </a:prstGeom>
+          <a:noFill/>
+        </p:spPr>
+        <p:txBody>
+          <a:bodyPr wrap="square">
+            <a:spAutoFit/>
+          </a:bodyPr>
+          <a:lstStyle/>
+          <a:p>
+            <a:pPr algn="l">
+              <a:defRPr sz="1800" b="1">
+                <a:solidFill>
+                  <a:srgbClr val="F39C12"/>
+                </a:solidFill>
+              </a:defRPr>
+            </a:pPr>
+            <a:r>
+              <a:t>기타 최적화 방향</a:t>
+            </a:r>
+          </a:p>
+          <a:p>
+            <a:pPr algn="l">
+              <a:defRPr sz="1000" b="0">
+                <a:solidFill>
+                  <a:srgbClr val="FFFFFF"/>
+                </a:solidFill>
+              </a:defRPr>
+            </a:pPr>
+          </a:p>
+          <a:p>
+            <a:pPr algn="l">
+              <a:defRPr sz="1500" b="1">
+                <a:solidFill>
+                  <a:srgbClr val="FFFFFF"/>
+                </a:solidFill>
+              </a:defRPr>
+            </a:pPr>
+            <a:r>
+              <a:t>JSON 구조화 출력</a:t>
+            </a:r>
+          </a:p>
+          <a:p>
+            <a:pPr algn="l">
+              <a:defRPr sz="1300" b="0">
+                <a:solidFill>
+                  <a:srgbClr val="BDBDBD"/>
+                </a:solidFill>
+              </a:defRPr>
+            </a:pPr>
+            <a:r>
+              <a:t>  프롬프트: 'Output as JSON: {ITEM, QTY}'</a:t>
+            </a:r>
+          </a:p>
+          <a:p>
+            <a:pPr algn="l">
+              <a:defRPr sz="1300" b="0">
+                <a:solidFill>
+                  <a:srgbClr val="BDBDBD"/>
+                </a:solidFill>
+              </a:defRPr>
+            </a:pPr>
+            <a:r>
+              <a:t>  -&gt; 후처리 파싱 자동화 용이</a:t>
+            </a:r>
+          </a:p>
+          <a:p>
+            <a:pPr algn="l">
+              <a:defRPr sz="1000" b="0">
+                <a:solidFill>
+                  <a:srgbClr val="FFFFFF"/>
+                </a:solidFill>
+              </a:defRPr>
+            </a:pPr>
+          </a:p>
+          <a:p>
+            <a:pPr algn="l">
+              <a:defRPr sz="1500" b="1">
+                <a:solidFill>
+                  <a:srgbClr val="FFFFFF"/>
+                </a:solidFill>
+              </a:defRPr>
+            </a:pPr>
+            <a:r>
+              <a:t>배치 처리 파이프라인</a:t>
+            </a:r>
+          </a:p>
+          <a:p>
+            <a:pPr algn="l">
+              <a:defRPr sz="1300" b="0">
+                <a:solidFill>
+                  <a:srgbClr val="BDBDBD"/>
+                </a:solidFill>
+              </a:defRPr>
+            </a:pPr>
+            <a:r>
+              <a:t>  이미지 전처리(크롭) + OCR 요청 병렬화</a:t>
+            </a:r>
+          </a:p>
+          <a:p>
+            <a:pPr algn="l">
+              <a:defRPr sz="1300" b="0">
+                <a:solidFill>
+                  <a:srgbClr val="BDBDBD"/>
+                </a:solidFill>
+              </a:defRPr>
+            </a:pPr>
+            <a:r>
+              <a:t>  다수 이미지 연속 처리시 throughput 향상</a:t>
+            </a:r>
+          </a:p>
+          <a:p>
+            <a:pPr algn="l">
+              <a:defRPr sz="1000" b="0">
+                <a:solidFill>
+                  <a:srgbClr val="FFFFFF"/>
+                </a:solidFill>
+              </a:defRPr>
+            </a:pPr>
+          </a:p>
+          <a:p>
+            <a:pPr algn="l">
+              <a:defRPr sz="1500" b="1">
+                <a:solidFill>
+                  <a:srgbClr val="FFFFFF"/>
+                </a:solidFill>
+              </a:defRPr>
+            </a:pPr>
+            <a:r>
+              <a:t>모델 업데이트 추적</a:t>
+            </a:r>
+          </a:p>
+          <a:p>
+            <a:pPr algn="l">
+              <a:defRPr sz="1300" b="0">
+                <a:solidFill>
+                  <a:srgbClr val="BDBDBD"/>
+                </a:solidFill>
+              </a:defRPr>
+            </a:pPr>
+            <a:r>
+              <a:t>  Qwen3.5 후속 버전 출시시</a:t>
+            </a:r>
+          </a:p>
+          <a:p>
+            <a:pPr algn="l">
+              <a:defRPr sz="1300" b="0">
+                <a:solidFill>
+                  <a:srgbClr val="BDBDBD"/>
+                </a:solidFill>
+              </a:defRPr>
+            </a:pPr>
+            <a:r>
+              <a:t>  0.8B 기본설정 정확도 개선 여부 재평가</a:t>
+            </a:r>
+          </a:p>
+          <a:p>
+            <a:pPr algn="l">
+              <a:defRPr sz="1300" b="0">
+                <a:solidFill>
+                  <a:srgbClr val="BDBDBD"/>
+                </a:solidFill>
+              </a:defRPr>
+            </a:pPr>
+            <a:r>
+              <a:t>  더 작고 빠른 모델 도입 가능성 열려있음</a:t>
+            </a:r>
+          </a:p>
+          <a:p>
+            <a:pPr algn="l">
+              <a:defRPr sz="1400" b="0">
+                <a:solidFill>
+                  <a:srgbClr val="FFFFFF"/>
+                </a:solidFill>
+              </a:defRPr>
+            </a:pPr>
+          </a:p>
+          <a:p>
+            <a:pPr algn="l">
+              <a:defRPr sz="1600" b="1">
+                <a:solidFill>
+                  <a:srgbClr val="2ECC71"/>
+                </a:solidFill>
+              </a:defRPr>
+            </a:pPr>
+            <a:r>
+              <a:t>현재 최적 구성</a:t>
+            </a:r>
+          </a:p>
+          <a:p>
+            <a:pPr algn="l">
+              <a:defRPr sz="1400" b="0">
+                <a:solidFill>
+                  <a:srgbClr val="2ECC71"/>
+                </a:solidFill>
+              </a:defRPr>
+            </a:pPr>
+            <a:r>
+              <a:t>  Qwen3.5-2B + llama-server</a:t>
+            </a:r>
+          </a:p>
+          <a:p>
+            <a:pPr algn="l">
+              <a:defRPr sz="1400" b="0">
+                <a:solidFill>
+                  <a:srgbClr val="2ECC71"/>
+                </a:solidFill>
+              </a:defRPr>
+            </a:pPr>
+            <a:r>
+              <a:t>  1.56초/장, 기본설정 100% 정확</a:t>
             </a:r>
           </a:p>
         </p:txBody>

</xml_diff>